<commit_message>
Final Review PPT: add presentation builder, reduce white heading font, fix slide 15 layout
</commit_message>
<xml_diff>
--- a/VARSA_Review_3.pptx
+++ b/VARSA_Review_3.pptx
@@ -3785,8 +3785,8 @@
         </p:nvSpPr>
         <p:spPr>
           <a:xfrm>
-            <a:off x="548640" y="548640"/>
-            <a:ext cx="11094720" cy="216000"/>
+            <a:off x="548640" y="288000"/>
+            <a:ext cx="11094720" cy="198000"/>
           </a:xfrm>
           <a:prstGeom prst="rect">
             <a:avLst/>
@@ -3820,7 +3820,7 @@
         </p:nvSpPr>
         <p:spPr>
           <a:xfrm>
-            <a:off x="548640" y="612000"/>
+            <a:off x="548640" y="522000"/>
             <a:ext cx="11094720" cy="540000"/>
           </a:xfrm>
           <a:prstGeom prst="rect">
@@ -4540,8 +4540,8 @@
         </p:nvSpPr>
         <p:spPr>
           <a:xfrm>
-            <a:off x="548640" y="548640"/>
-            <a:ext cx="11094720" cy="216000"/>
+            <a:off x="548640" y="288000"/>
+            <a:ext cx="11094720" cy="198000"/>
           </a:xfrm>
           <a:prstGeom prst="rect">
             <a:avLst/>
@@ -4575,7 +4575,7 @@
         </p:nvSpPr>
         <p:spPr>
           <a:xfrm>
-            <a:off x="548640" y="612000"/>
+            <a:off x="548640" y="522000"/>
             <a:ext cx="11094720" cy="540000"/>
           </a:xfrm>
           <a:prstGeom prst="rect">
@@ -5443,8 +5443,8 @@
         </p:nvSpPr>
         <p:spPr>
           <a:xfrm>
-            <a:off x="548640" y="548640"/>
-            <a:ext cx="11094720" cy="216000"/>
+            <a:off x="548640" y="288000"/>
+            <a:ext cx="11094720" cy="198000"/>
           </a:xfrm>
           <a:prstGeom prst="rect">
             <a:avLst/>
@@ -5478,7 +5478,7 @@
         </p:nvSpPr>
         <p:spPr>
           <a:xfrm>
-            <a:off x="548640" y="612000"/>
+            <a:off x="548640" y="522000"/>
             <a:ext cx="11094720" cy="540000"/>
           </a:xfrm>
           <a:prstGeom prst="rect">
@@ -6346,8 +6346,8 @@
         </p:nvSpPr>
         <p:spPr>
           <a:xfrm>
-            <a:off x="548640" y="548640"/>
-            <a:ext cx="11094720" cy="216000"/>
+            <a:off x="548640" y="288000"/>
+            <a:ext cx="11094720" cy="198000"/>
           </a:xfrm>
           <a:prstGeom prst="rect">
             <a:avLst/>
@@ -6381,7 +6381,7 @@
         </p:nvSpPr>
         <p:spPr>
           <a:xfrm>
-            <a:off x="548640" y="612000"/>
+            <a:off x="548640" y="522000"/>
             <a:ext cx="11094720" cy="540000"/>
           </a:xfrm>
           <a:prstGeom prst="rect">
@@ -7101,8 +7101,8 @@
         </p:nvSpPr>
         <p:spPr>
           <a:xfrm>
-            <a:off x="548640" y="548640"/>
-            <a:ext cx="11094720" cy="216000"/>
+            <a:off x="548640" y="288000"/>
+            <a:ext cx="11094720" cy="198000"/>
           </a:xfrm>
           <a:prstGeom prst="rect">
             <a:avLst/>
@@ -7136,7 +7136,7 @@
         </p:nvSpPr>
         <p:spPr>
           <a:xfrm>
-            <a:off x="548640" y="612000"/>
+            <a:off x="548640" y="522000"/>
             <a:ext cx="11094720" cy="540000"/>
           </a:xfrm>
           <a:prstGeom prst="rect">
@@ -8004,8 +8004,8 @@
         </p:nvSpPr>
         <p:spPr>
           <a:xfrm>
-            <a:off x="548640" y="548640"/>
-            <a:ext cx="11094720" cy="216000"/>
+            <a:off x="548640" y="288000"/>
+            <a:ext cx="11094720" cy="198000"/>
           </a:xfrm>
           <a:prstGeom prst="rect">
             <a:avLst/>
@@ -8039,7 +8039,7 @@
         </p:nvSpPr>
         <p:spPr>
           <a:xfrm>
-            <a:off x="548640" y="612000"/>
+            <a:off x="548640" y="522000"/>
             <a:ext cx="11094720" cy="540000"/>
           </a:xfrm>
           <a:prstGeom prst="rect">
@@ -8953,8 +8953,8 @@
         </p:nvSpPr>
         <p:spPr>
           <a:xfrm>
-            <a:off x="548640" y="548640"/>
-            <a:ext cx="11094720" cy="216000"/>
+            <a:off x="548640" y="288000"/>
+            <a:ext cx="11094720" cy="198000"/>
           </a:xfrm>
           <a:prstGeom prst="rect">
             <a:avLst/>
@@ -8988,7 +8988,7 @@
         </p:nvSpPr>
         <p:spPr>
           <a:xfrm>
-            <a:off x="548640" y="612000"/>
+            <a:off x="548640" y="522000"/>
             <a:ext cx="11094720" cy="540000"/>
           </a:xfrm>
           <a:prstGeom prst="rect">
@@ -10082,8 +10082,8 @@
         </p:nvSpPr>
         <p:spPr>
           <a:xfrm>
-            <a:off x="548640" y="548640"/>
-            <a:ext cx="11094720" cy="216000"/>
+            <a:off x="548640" y="288000"/>
+            <a:ext cx="11094720" cy="198000"/>
           </a:xfrm>
           <a:prstGeom prst="rect">
             <a:avLst/>
@@ -10117,7 +10117,7 @@
         </p:nvSpPr>
         <p:spPr>
           <a:xfrm>
-            <a:off x="548640" y="612000"/>
+            <a:off x="548640" y="522000"/>
             <a:ext cx="11094720" cy="540000"/>
           </a:xfrm>
           <a:prstGeom prst="rect">
@@ -11353,8 +11353,8 @@
         </p:nvSpPr>
         <p:spPr>
           <a:xfrm>
-            <a:off x="548640" y="548640"/>
-            <a:ext cx="11094720" cy="216000"/>
+            <a:off x="548640" y="288000"/>
+            <a:ext cx="11094720" cy="198000"/>
           </a:xfrm>
           <a:prstGeom prst="rect">
             <a:avLst/>
@@ -11388,7 +11388,7 @@
         </p:nvSpPr>
         <p:spPr>
           <a:xfrm>
-            <a:off x="548640" y="612000"/>
+            <a:off x="548640" y="522000"/>
             <a:ext cx="11094720" cy="540000"/>
           </a:xfrm>
           <a:prstGeom prst="rect">
@@ -12170,8 +12170,8 @@
         </p:nvSpPr>
         <p:spPr>
           <a:xfrm>
-            <a:off x="548640" y="548640"/>
-            <a:ext cx="11094720" cy="216000"/>
+            <a:off x="548640" y="288000"/>
+            <a:ext cx="11094720" cy="198000"/>
           </a:xfrm>
           <a:prstGeom prst="rect">
             <a:avLst/>
@@ -12205,7 +12205,7 @@
         </p:nvSpPr>
         <p:spPr>
           <a:xfrm>
-            <a:off x="548640" y="612000"/>
+            <a:off x="548640" y="522000"/>
             <a:ext cx="11094720" cy="540000"/>
           </a:xfrm>
           <a:prstGeom prst="rect">
@@ -13283,8 +13283,8 @@
         </p:nvSpPr>
         <p:spPr>
           <a:xfrm>
-            <a:off x="548640" y="548640"/>
-            <a:ext cx="11094720" cy="216000"/>
+            <a:off x="548640" y="288000"/>
+            <a:ext cx="11094720" cy="198000"/>
           </a:xfrm>
           <a:prstGeom prst="rect">
             <a:avLst/>
@@ -13318,7 +13318,7 @@
         </p:nvSpPr>
         <p:spPr>
           <a:xfrm>
-            <a:off x="548640" y="612000"/>
+            <a:off x="548640" y="522000"/>
             <a:ext cx="11094720" cy="540000"/>
           </a:xfrm>
           <a:prstGeom prst="rect">
@@ -14162,8 +14162,8 @@
         </p:nvSpPr>
         <p:spPr>
           <a:xfrm>
-            <a:off x="548640" y="548640"/>
-            <a:ext cx="11094720" cy="216000"/>
+            <a:off x="548640" y="288000"/>
+            <a:ext cx="11094720" cy="198000"/>
           </a:xfrm>
           <a:prstGeom prst="rect">
             <a:avLst/>
@@ -14197,7 +14197,7 @@
         </p:nvSpPr>
         <p:spPr>
           <a:xfrm>
-            <a:off x="548640" y="612000"/>
+            <a:off x="548640" y="522000"/>
             <a:ext cx="11094720" cy="540000"/>
           </a:xfrm>
           <a:prstGeom prst="rect">
@@ -15310,8 +15310,8 @@
         </p:nvSpPr>
         <p:spPr>
           <a:xfrm>
-            <a:off x="548640" y="548640"/>
-            <a:ext cx="11094720" cy="216000"/>
+            <a:off x="548640" y="288000"/>
+            <a:ext cx="11094720" cy="198000"/>
           </a:xfrm>
           <a:prstGeom prst="rect">
             <a:avLst/>
@@ -15345,7 +15345,7 @@
         </p:nvSpPr>
         <p:spPr>
           <a:xfrm>
-            <a:off x="548640" y="612000"/>
+            <a:off x="548640" y="522000"/>
             <a:ext cx="11094720" cy="540000"/>
           </a:xfrm>
           <a:prstGeom prst="rect">
@@ -16743,8 +16743,8 @@
         </p:nvSpPr>
         <p:spPr>
           <a:xfrm>
-            <a:off x="548640" y="548640"/>
-            <a:ext cx="11094720" cy="216000"/>
+            <a:off x="548640" y="288000"/>
+            <a:ext cx="11094720" cy="198000"/>
           </a:xfrm>
           <a:prstGeom prst="rect">
             <a:avLst/>
@@ -16778,7 +16778,7 @@
         </p:nvSpPr>
         <p:spPr>
           <a:xfrm>
-            <a:off x="548640" y="612000"/>
+            <a:off x="548640" y="522000"/>
             <a:ext cx="11094720" cy="540000"/>
           </a:xfrm>
           <a:prstGeom prst="rect">
@@ -18176,8 +18176,8 @@
         </p:nvSpPr>
         <p:spPr>
           <a:xfrm>
-            <a:off x="548640" y="548640"/>
-            <a:ext cx="11094720" cy="216000"/>
+            <a:off x="548640" y="288000"/>
+            <a:ext cx="11094720" cy="198000"/>
           </a:xfrm>
           <a:prstGeom prst="rect">
             <a:avLst/>
@@ -18211,7 +18211,7 @@
         </p:nvSpPr>
         <p:spPr>
           <a:xfrm>
-            <a:off x="548640" y="612000"/>
+            <a:off x="548640" y="522000"/>
             <a:ext cx="11094720" cy="540000"/>
           </a:xfrm>
           <a:prstGeom prst="rect">
@@ -18931,8 +18931,8 @@
         </p:nvSpPr>
         <p:spPr>
           <a:xfrm>
-            <a:off x="548640" y="548640"/>
-            <a:ext cx="11094720" cy="216000"/>
+            <a:off x="548640" y="288000"/>
+            <a:ext cx="11094720" cy="198000"/>
           </a:xfrm>
           <a:prstGeom prst="rect">
             <a:avLst/>
@@ -18966,7 +18966,7 @@
         </p:nvSpPr>
         <p:spPr>
           <a:xfrm>
-            <a:off x="548640" y="612000"/>
+            <a:off x="548640" y="522000"/>
             <a:ext cx="11094720" cy="540000"/>
           </a:xfrm>
           <a:prstGeom prst="rect">

</xml_diff>